<commit_message>
Rebrand to StormChain across repo, report, presentation, and dashboard
</commit_message>
<xml_diff>
--- a/report/presentation.pptx
+++ b/report/presentation.pptx
@@ -3128,7 +3128,7 @@
             </a:pPr>
             <a:r>
               <a:rPr/>
-              <a:t>Airline Crew Sequences Meet Bad Weather</a:t>
+              <a:t>StormChain</a:t>
             </a:r>
           </a:p>
         </p:txBody>
@@ -3158,7 +3158,7 @@
             </a:pPr>
             <a:r>
               <a:rPr/>
-              <a:t>EPPS-American Airlines Data Challenge — GROW 26.2</a:t>
+              <a:t>Airline Crew Sequences Meet Bad Weather — EPPS-American Airlines Data Challenge</a:t>
             </a:r>
             <a:br/>
             <a:br/>
@@ -3862,7 +3862,7 @@
             </a:pPr>
             <a:r>
               <a:rPr b="1"/>
-              <a:t>Airline Crew Sequences Meet Bad Weather</a:t>
+              <a:t>StormChain</a:t>
             </a:r>
           </a:p>
           <a:p>
@@ -3870,8 +3870,17 @@
               <a:buNone/>
             </a:pPr>
             <a:r>
-              <a:rPr/>
+              <a:rPr i="1"/>
               <a:t>Identifying pilot flight pairings through DFW that should not share a sequence</a:t>
+            </a:r>
+          </a:p>
+          <a:p>
+            <a:pPr lvl="0" indent="0" marL="0">
+              <a:buNone/>
+            </a:pPr>
+            <a:r>
+              <a:rPr/>
+              <a:t>EPPS-American Airlines Data Challenge — GROW 26.2</a:t>
             </a:r>
           </a:p>
         </p:txBody>

</xml_diff>